<commit_message>
Fix dbt deprecation warnings — update accepted_values syntax
</commit_message>
<xml_diff>
--- a/deliverables/Maven_toys_report.pptx
+++ b/deliverables/Maven_toys_report.pptx
@@ -9901,21 +9901,21 @@
                 <a:latin typeface="Times New Roman" panose="02020603050405020304" pitchFamily="18" charset="0"/>
                 <a:cs typeface="Times New Roman" panose="02020603050405020304" pitchFamily="18" charset="0"/>
               </a:rPr>
-              <a:t>Greatest inventory risks are at Decem</a:t>
-            </a:r>
-            <a:r>
-              <a:rPr lang="en-US" dirty="0" err="1">
+              <a:t>Greatest inventory risks are at </a:t>
+            </a:r>
+            <a:r>
+              <a:rPr lang="en-US" dirty="0">
                 <a:latin typeface="Times New Roman" panose="02020603050405020304" pitchFamily="18" charset="0"/>
                 <a:cs typeface="Times New Roman" panose="02020603050405020304" pitchFamily="18" charset="0"/>
               </a:rPr>
-              <a:t>ber</a:t>
+              <a:t>December </a:t>
             </a:r>
             <a:r>
               <a:rPr lang="lt-LT" dirty="0">
                 <a:latin typeface="Times New Roman" panose="02020603050405020304" pitchFamily="18" charset="0"/>
                 <a:cs typeface="Times New Roman" panose="02020603050405020304" pitchFamily="18" charset="0"/>
               </a:rPr>
-              <a:t> and April, check inventory before those months and stock up if needed. </a:t>
+              <a:t>and April, check inventory before those months and stock up if needed. </a:t>
             </a:r>
           </a:p>
           <a:p>

</xml_diff>